<commit_message>
phase3: close evidence figure and incremental lineage gates
</commit_message>
<xml_diff>
--- a/thesis-deck-system/artifacts/phase3/cp5-final-visual-composition-acceptance-deck.pptx
+++ b/thesis-deck-system/artifacts/phase3/cp5-final-visual-composition-acceptance-deck.pptx
@@ -5466,7 +5466,7 @@
               <a:rPr sz="2000">
                 <a:latin typeface="Arial"/>
               </a:rPr>
-              <a:t>time / synthetic</a:t>
+              <a:t>condition / canonical_index</a:t>
             </a:r>
           </a:p>
         </p:txBody>
@@ -5497,7 +5497,7 @@
               <a:rPr sz="2000">
                 <a:latin typeface="Arial"/>
               </a:rPr>
-              <a:t>response / synthetic</a:t>
+              <a:t>mean conductivity increase / %</a:t>
             </a:r>
           </a:p>
         </p:txBody>
@@ -5528,7 +5528,7 @@
               <a:rPr sz="1600">
                 <a:latin typeface="Arial"/>
               </a:rPr>
-              <a:t>1–2</a:t>
+              <a:t>0–24</a:t>
             </a:r>
           </a:p>
         </p:txBody>
@@ -5854,7 +5854,7 @@
               <a:rPr sz="2000">
                 <a:latin typeface="Arial"/>
               </a:rPr>
-              <a:t>time / synthetic</a:t>
+              <a:t>condition / canonical_index</a:t>
             </a:r>
           </a:p>
         </p:txBody>
@@ -5885,7 +5885,7 @@
               <a:rPr sz="2000">
                 <a:latin typeface="Arial"/>
               </a:rPr>
-              <a:t>response / synthetic</a:t>
+              <a:t>signal CV decrease / %</a:t>
             </a:r>
           </a:p>
         </p:txBody>
@@ -5916,7 +5916,7 @@
               <a:rPr sz="1600">
                 <a:latin typeface="Arial"/>
               </a:rPr>
-              <a:t>1–2</a:t>
+              <a:t>0–4</a:t>
             </a:r>
           </a:p>
         </p:txBody>
@@ -6480,7 +6480,7 @@
               <a:rPr sz="2000">
                 <a:latin typeface="Arial"/>
               </a:rPr>
-              <a:t>Input</a:t>
+              <a:t>C101</a:t>
             </a:r>
           </a:p>
         </p:txBody>
@@ -6556,7 +6556,7 @@
               <a:rPr sz="2000">
                 <a:latin typeface="Arial"/>
               </a:rPr>
-              <a:t>Unknown</a:t>
+              <a:t>C201</a:t>
             </a:r>
           </a:p>
         </p:txBody>
@@ -6980,7 +6980,7 @@
       </p:sp>
       <p:pic>
         <p:nvPicPr>
-          <p:cNvPr id="4" name="tds-svg-fallback:FB001-REV2/S-H002-FISHBONE-LOCATOR-03" descr="FB001-rev2.png"/>
+          <p:cNvPr id="4" name="tds-raster-fallback:FB001-REV2/S-H002-FISHBONE-LOCATOR-03" descr="FB001-rev2.png"/>
           <p:cNvPicPr>
             <a:picLocks noChangeAspect="1"/>
           </p:cNvPicPr>
@@ -7320,7 +7320,7 @@
               <a:rPr sz="2000">
                 <a:latin typeface="Arial"/>
               </a:rPr>
-              <a:t>Input</a:t>
+              <a:t>contact resistance</a:t>
             </a:r>
           </a:p>
         </p:txBody>
@@ -7396,7 +7396,7 @@
               <a:rPr sz="2000">
                 <a:latin typeface="Arial"/>
               </a:rPr>
-              <a:t>Unknown</a:t>
+              <a:t>51</a:t>
             </a:r>
           </a:p>
         </p:txBody>
@@ -7877,7 +7877,7 @@
               <a:rPr sz="1800">
                 <a:latin typeface="Arial"/>
               </a:rPr>
-              <a:t>metric · same scale</a:t>
+              <a:t>signal CV decrease (%) · same scale</a:t>
             </a:r>
           </a:p>
         </p:txBody>
@@ -8019,7 +8019,7 @@
               <a:rPr sz="1800">
                 <a:latin typeface="Arial"/>
               </a:rPr>
-              <a:t>metric · same scale</a:t>
+              <a:t>signal CV decrease (%) · same scale</a:t>
             </a:r>
           </a:p>
         </p:txBody>
@@ -8650,7 +8650,7 @@
       </p:sp>
       <p:pic>
         <p:nvPicPr>
-          <p:cNvPr id="4" name="tds-svg-fallback:FB001-REV1/S-H001-FISHBONE-LOCATOR-03" descr="FB001-rev1.png"/>
+          <p:cNvPr id="4" name="tds-raster-fallback:FB001-REV1/S-H001-FISHBONE-LOCATOR-03" descr="FB001-rev1.png"/>
           <p:cNvPicPr>
             <a:picLocks noChangeAspect="1"/>
           </p:cNvPicPr>
@@ -8934,7 +8934,7 @@
               <a:rPr sz="2000">
                 <a:latin typeface="Arial"/>
               </a:rPr>
-              <a:t>Input</a:t>
+              <a:t>23</a:t>
             </a:r>
           </a:p>
         </p:txBody>
@@ -9010,7 +9010,7 @@
               <a:rPr sz="2000">
                 <a:latin typeface="Arial"/>
               </a:rPr>
-              <a:t>Unknown</a:t>
+              <a:t>提升 bulk conductivity 是否足以降低位置依賴的訊號變異？</a:t>
             </a:r>
           </a:p>
         </p:txBody>
@@ -9412,7 +9412,7 @@
               <a:rPr sz="2000">
                 <a:latin typeface="Arial"/>
               </a:rPr>
-              <a:t>Input</a:t>
+              <a:t>bulk transport</a:t>
             </a:r>
           </a:p>
         </p:txBody>
@@ -9488,7 +9488,7 @@
               <a:rPr sz="2000">
                 <a:latin typeface="Arial"/>
               </a:rPr>
-              <a:t>Unknown</a:t>
+              <a:t>23</a:t>
             </a:r>
           </a:p>
         </p:txBody>
@@ -9918,7 +9918,7 @@
               <a:rPr sz="1800">
                 <a:latin typeface="Arial"/>
               </a:rPr>
-              <a:t>sample</a:t>
+              <a:t>replicates: 3; samples: 15</a:t>
             </a:r>
           </a:p>
         </p:txBody>
@@ -9994,7 +9994,7 @@
               <a:rPr sz="1800">
                 <a:latin typeface="Arial"/>
               </a:rPr>
-              <a:t>baseline</a:t>
+              <a:t>原始配方</a:t>
             </a:r>
           </a:p>
         </p:txBody>
@@ -10070,7 +10070,7 @@
               <a:rPr sz="1800">
                 <a:latin typeface="Arial"/>
               </a:rPr>
-              <a:t>instrument</a:t>
+              <a:t>synthetic-four-probe</a:t>
             </a:r>
           </a:p>
         </p:txBody>
@@ -10146,7 +10146,7 @@
               <a:rPr sz="1800">
                 <a:latin typeface="Arial"/>
               </a:rPr>
-              <a:t>probe</a:t>
+              <a:t>導電度 (mS/cm)</a:t>
             </a:r>
           </a:p>
         </p:txBody>
@@ -10222,7 +10222,7 @@
               <a:rPr sz="1800">
                 <a:latin typeface="Arial"/>
               </a:rPr>
-              <a:t>signal</a:t>
+              <a:t>含水量</a:t>
             </a:r>
           </a:p>
         </p:txBody>
@@ -10298,7 +10298,7 @@
               <a:rPr sz="1800">
                 <a:latin typeface="Arial"/>
               </a:rPr>
-              <a:t>measurement</a:t>
+              <a:t>導電度 (mS/cm)</a:t>
             </a:r>
           </a:p>
         </p:txBody>
@@ -10621,7 +10621,7 @@
               <a:rPr sz="1800">
                 <a:latin typeface="Arial"/>
               </a:rPr>
-              <a:t>sample</a:t>
+              <a:t>replicates: 3; samples: 15</a:t>
             </a:r>
           </a:p>
         </p:txBody>
@@ -10697,7 +10697,7 @@
               <a:rPr sz="1800">
                 <a:latin typeface="Arial"/>
               </a:rPr>
-              <a:t>baseline</a:t>
+              <a:t>原始位置分布</a:t>
             </a:r>
           </a:p>
         </p:txBody>
@@ -10773,7 +10773,7 @@
               <a:rPr sz="1800">
                 <a:latin typeface="Arial"/>
               </a:rPr>
-              <a:t>instrument</a:t>
+              <a:t>synthetic-signal-test</a:t>
             </a:r>
           </a:p>
         </p:txBody>
@@ -10849,7 +10849,7 @@
               <a:rPr sz="1800">
                 <a:latin typeface="Arial"/>
               </a:rPr>
-              <a:t>probe</a:t>
+              <a:t>訊號 CV (%)</a:t>
             </a:r>
           </a:p>
         </p:txBody>
@@ -10925,7 +10925,7 @@
               <a:rPr sz="1800">
                 <a:latin typeface="Arial"/>
               </a:rPr>
-              <a:t>signal</a:t>
+              <a:t>位置</a:t>
             </a:r>
           </a:p>
         </p:txBody>
@@ -11001,7 +11001,7 @@
               <a:rPr sz="1800">
                 <a:latin typeface="Arial"/>
               </a:rPr>
-              <a:t>measurement</a:t>
+              <a:t>訊號 CV (%)</a:t>
             </a:r>
           </a:p>
         </p:txBody>

</xml_diff>